<commit_message>
Affine le design du support (charte graphique BdF plus stricte)
Ombres portées remplacées par des bordures fines (rendu plat et
institutionnel, sans effet 3D), et rééquilibrage des couleurs par
diapositive : bleu #003DA5 dominant, cyan en repère secondaire, une
seule couleur chaude d'accent maximum par slide (H2 et la
décomposition SHAP H3 utilisaient chacune deux teintes chaudes).
</commit_message>
<xml_diff>
--- a/presentation/memoire_soutenance_BdF.pptx
+++ b/presentation/memoire_soutenance_BdF.pptx
@@ -651,7 +651,7 @@
           </c:tx>
           <c:spPr>
             <a:solidFill>
-              <a:srgbClr val="FF8200"/>
+              <a:srgbClr val="003DA5"/>
             </a:solidFill>
             <a:effectLst/>
           </c:spPr>
@@ -748,7 +748,7 @@
           </c:tx>
           <c:spPr>
             <a:solidFill>
-              <a:srgbClr val="A6192E"/>
+              <a:srgbClr val="009FDF"/>
             </a:solidFill>
             <a:effectLst/>
           </c:spPr>
@@ -845,7 +845,7 @@
           </c:tx>
           <c:spPr>
             <a:solidFill>
-              <a:srgbClr val="003DA5"/>
+              <a:srgbClr val="00B398"/>
             </a:solidFill>
             <a:effectLst/>
           </c:spPr>
@@ -942,7 +942,7 @@
           </c:tx>
           <c:spPr>
             <a:solidFill>
-              <a:srgbClr val="009FDF"/>
+              <a:srgbClr val="001E60"/>
             </a:solidFill>
             <a:effectLst/>
           </c:spPr>
@@ -1039,7 +1039,7 @@
           </c:tx>
           <c:spPr>
             <a:solidFill>
-              <a:srgbClr val="00B398"/>
+              <a:srgbClr val="FFB600"/>
             </a:solidFill>
             <a:effectLst/>
           </c:spPr>
@@ -1136,7 +1136,7 @@
           </c:tx>
           <c:spPr>
             <a:solidFill>
-              <a:srgbClr val="C9CFDA"/>
+              <a:srgbClr val="8B95AA"/>
             </a:solidFill>
             <a:effectLst/>
           </c:spPr>
@@ -4643,14 +4643,12 @@
           <a:solidFill>
             <a:srgbClr val="F4F6FB"/>
           </a:solidFill>
-          <a:ln/>
-          <a:effectLst>
-            <a:outerShdw sx="100000" sy="100000" kx="0" ky="0" algn="bl" rotWithShape="0" blurRad="76200" dist="25400" dir="5400000">
-              <a:srgbClr val="9AA5B8">
-                <a:alpha val="25000"/>
-              </a:srgbClr>
-            </a:outerShdw>
-          </a:effectLst>
+          <a:ln w="9525">
+            <a:solidFill>
+              <a:srgbClr val="E1E6F0"/>
+            </a:solidFill>
+            <a:prstDash val="solid"/>
+          </a:ln>
         </p:spPr>
       </p:sp>
       <p:sp>
@@ -4840,14 +4838,12 @@
           <a:solidFill>
             <a:srgbClr val="F4F6FB"/>
           </a:solidFill>
-          <a:ln/>
-          <a:effectLst>
-            <a:outerShdw sx="100000" sy="100000" kx="0" ky="0" algn="bl" rotWithShape="0" blurRad="76200" dist="25400" dir="5400000">
-              <a:srgbClr val="9AA5B8">
-                <a:alpha val="25000"/>
-              </a:srgbClr>
-            </a:outerShdw>
-          </a:effectLst>
+          <a:ln w="9525">
+            <a:solidFill>
+              <a:srgbClr val="E1E6F0"/>
+            </a:solidFill>
+            <a:prstDash val="solid"/>
+          </a:ln>
         </p:spPr>
       </p:sp>
       <p:sp>
@@ -6696,14 +6692,12 @@
           <a:solidFill>
             <a:srgbClr val="F4F6FB"/>
           </a:solidFill>
-          <a:ln/>
-          <a:effectLst>
-            <a:outerShdw sx="100000" sy="100000" kx="0" ky="0" algn="bl" rotWithShape="0" blurRad="76200" dist="25400" dir="5400000">
-              <a:srgbClr val="9AA5B8">
-                <a:alpha val="22000"/>
-              </a:srgbClr>
-            </a:outerShdw>
-          </a:effectLst>
+          <a:ln w="9525">
+            <a:solidFill>
+              <a:srgbClr val="E1E6F0"/>
+            </a:solidFill>
+            <a:prstDash val="solid"/>
+          </a:ln>
         </p:spPr>
       </p:sp>
       <p:sp>
@@ -7770,14 +7764,12 @@
           <a:solidFill>
             <a:srgbClr val="F4F6FB"/>
           </a:solidFill>
-          <a:ln/>
-          <a:effectLst>
-            <a:outerShdw sx="100000" sy="100000" kx="0" ky="0" algn="bl" rotWithShape="0" blurRad="76200" dist="25400" dir="5400000">
-              <a:srgbClr val="9AA5B8">
-                <a:alpha val="22000"/>
-              </a:srgbClr>
-            </a:outerShdw>
-          </a:effectLst>
+          <a:ln w="9525">
+            <a:solidFill>
+              <a:srgbClr val="E1E6F0"/>
+            </a:solidFill>
+            <a:prstDash val="solid"/>
+          </a:ln>
         </p:spPr>
       </p:sp>
       <p:sp>
@@ -8077,14 +8069,12 @@
           <a:solidFill>
             <a:srgbClr val="F4F6FB"/>
           </a:solidFill>
-          <a:ln/>
-          <a:effectLst>
-            <a:outerShdw sx="100000" sy="100000" kx="0" ky="0" algn="bl" rotWithShape="0" blurRad="76200" dist="25400" dir="5400000">
-              <a:srgbClr val="9AA5B8">
-                <a:alpha val="22000"/>
-              </a:srgbClr>
-            </a:outerShdw>
-          </a:effectLst>
+          <a:ln w="9525">
+            <a:solidFill>
+              <a:srgbClr val="E1E6F0"/>
+            </a:solidFill>
+            <a:prstDash val="solid"/>
+          </a:ln>
         </p:spPr>
       </p:sp>
       <p:sp>
@@ -8104,7 +8094,7 @@
             </a:avLst>
           </a:prstGeom>
           <a:solidFill>
-            <a:srgbClr val="FF8200"/>
+            <a:srgbClr val="009FDF"/>
           </a:solidFill>
           <a:ln/>
         </p:spPr>
@@ -8353,7 +8343,7 @@
             <a:r>
               <a:rPr lang="en-US" sz="1250" b="1" dirty="0">
                 <a:solidFill>
-                  <a:srgbClr val="FF8200"/>
+                  <a:srgbClr val="009FDF"/>
                 </a:solidFill>
                 <a:latin typeface="Calibri" pitchFamily="34" charset="0"/>
                 <a:ea typeface="Calibri" pitchFamily="34" charset="-122"/>
@@ -8384,14 +8374,12 @@
           <a:solidFill>
             <a:srgbClr val="F4F6FB"/>
           </a:solidFill>
-          <a:ln/>
-          <a:effectLst>
-            <a:outerShdw sx="100000" sy="100000" kx="0" ky="0" algn="bl" rotWithShape="0" blurRad="76200" dist="25400" dir="5400000">
-              <a:srgbClr val="9AA5B8">
-                <a:alpha val="22000"/>
-              </a:srgbClr>
-            </a:outerShdw>
-          </a:effectLst>
+          <a:ln w="9525">
+            <a:solidFill>
+              <a:srgbClr val="E1E6F0"/>
+            </a:solidFill>
+            <a:prstDash val="solid"/>
+          </a:ln>
         </p:spPr>
       </p:sp>
       <p:sp>
@@ -8937,14 +8925,12 @@
           <a:solidFill>
             <a:srgbClr val="F4F6FB"/>
           </a:solidFill>
-          <a:ln/>
-          <a:effectLst>
-            <a:outerShdw sx="100000" sy="100000" kx="0" ky="0" algn="bl" rotWithShape="0" blurRad="76200" dist="25400" dir="5400000">
-              <a:srgbClr val="9AA5B8">
-                <a:alpha val="25000"/>
-              </a:srgbClr>
-            </a:outerShdw>
-          </a:effectLst>
+          <a:ln w="9525">
+            <a:solidFill>
+              <a:srgbClr val="E1E6F0"/>
+            </a:solidFill>
+            <a:prstDash val="solid"/>
+          </a:ln>
         </p:spPr>
       </p:sp>
       <p:sp>
@@ -8962,7 +8948,7 @@
             <a:avLst/>
           </a:prstGeom>
           <a:solidFill>
-            <a:srgbClr val="003DA5"/>
+            <a:srgbClr val="009FDF"/>
           </a:solidFill>
           <a:ln/>
         </p:spPr>
@@ -9094,14 +9080,12 @@
           <a:solidFill>
             <a:srgbClr val="F4F6FB"/>
           </a:solidFill>
-          <a:ln/>
-          <a:effectLst>
-            <a:outerShdw sx="100000" sy="100000" kx="0" ky="0" algn="bl" rotWithShape="0" blurRad="76200" dist="25400" dir="5400000">
-              <a:srgbClr val="9AA5B8">
-                <a:alpha val="25000"/>
-              </a:srgbClr>
-            </a:outerShdw>
-          </a:effectLst>
+          <a:ln w="9525">
+            <a:solidFill>
+              <a:srgbClr val="E1E6F0"/>
+            </a:solidFill>
+            <a:prstDash val="solid"/>
+          </a:ln>
         </p:spPr>
       </p:sp>
       <p:sp>
@@ -9119,7 +9103,7 @@
             <a:avLst/>
           </a:prstGeom>
           <a:solidFill>
-            <a:srgbClr val="FF8200"/>
+            <a:srgbClr val="003DA5"/>
           </a:solidFill>
           <a:ln/>
         </p:spPr>
@@ -11782,14 +11766,12 @@
           <a:solidFill>
             <a:srgbClr val="F4F6FB"/>
           </a:solidFill>
-          <a:ln/>
-          <a:effectLst>
-            <a:outerShdw sx="100000" sy="100000" kx="0" ky="0" algn="bl" rotWithShape="0" blurRad="76200" dist="25400" dir="5400000">
-              <a:srgbClr val="9AA5B8">
-                <a:alpha val="25000"/>
-              </a:srgbClr>
-            </a:outerShdw>
-          </a:effectLst>
+          <a:ln w="9525">
+            <a:solidFill>
+              <a:srgbClr val="E1E6F0"/>
+            </a:solidFill>
+            <a:prstDash val="solid"/>
+          </a:ln>
         </p:spPr>
       </p:sp>
       <p:sp>
@@ -11968,14 +11950,12 @@
           <a:solidFill>
             <a:srgbClr val="F4F6FB"/>
           </a:solidFill>
-          <a:ln/>
-          <a:effectLst>
-            <a:outerShdw sx="100000" sy="100000" kx="0" ky="0" algn="bl" rotWithShape="0" blurRad="76200" dist="25400" dir="5400000">
-              <a:srgbClr val="9AA5B8">
-                <a:alpha val="25000"/>
-              </a:srgbClr>
-            </a:outerShdw>
-          </a:effectLst>
+          <a:ln w="9525">
+            <a:solidFill>
+              <a:srgbClr val="E1E6F0"/>
+            </a:solidFill>
+            <a:prstDash val="solid"/>
+          </a:ln>
         </p:spPr>
       </p:sp>
       <p:sp>
@@ -13867,14 +13847,12 @@
           <a:solidFill>
             <a:srgbClr val="F4F6FB"/>
           </a:solidFill>
-          <a:ln/>
-          <a:effectLst>
-            <a:outerShdw sx="100000" sy="100000" kx="0" ky="0" algn="bl" rotWithShape="0" blurRad="76200" dist="25400" dir="5400000">
-              <a:srgbClr val="9AA5B8">
-                <a:alpha val="22000"/>
-              </a:srgbClr>
-            </a:outerShdw>
-          </a:effectLst>
+          <a:ln w="9525">
+            <a:solidFill>
+              <a:srgbClr val="E1E6F0"/>
+            </a:solidFill>
+            <a:prstDash val="solid"/>
+          </a:ln>
         </p:spPr>
       </p:sp>
       <p:sp>
@@ -14057,14 +14035,12 @@
           <a:solidFill>
             <a:srgbClr val="F4F6FB"/>
           </a:solidFill>
-          <a:ln/>
-          <a:effectLst>
-            <a:outerShdw sx="100000" sy="100000" kx="0" ky="0" algn="bl" rotWithShape="0" blurRad="76200" dist="25400" dir="5400000">
-              <a:srgbClr val="9AA5B8">
-                <a:alpha val="22000"/>
-              </a:srgbClr>
-            </a:outerShdw>
-          </a:effectLst>
+          <a:ln w="9525">
+            <a:solidFill>
+              <a:srgbClr val="E1E6F0"/>
+            </a:solidFill>
+            <a:prstDash val="solid"/>
+          </a:ln>
         </p:spPr>
       </p:sp>
       <p:sp>
@@ -14247,14 +14223,12 @@
           <a:solidFill>
             <a:srgbClr val="F4F6FB"/>
           </a:solidFill>
-          <a:ln/>
-          <a:effectLst>
-            <a:outerShdw sx="100000" sy="100000" kx="0" ky="0" algn="bl" rotWithShape="0" blurRad="76200" dist="25400" dir="5400000">
-              <a:srgbClr val="9AA5B8">
-                <a:alpha val="22000"/>
-              </a:srgbClr>
-            </a:outerShdw>
-          </a:effectLst>
+          <a:ln w="9525">
+            <a:solidFill>
+              <a:srgbClr val="E1E6F0"/>
+            </a:solidFill>
+            <a:prstDash val="solid"/>
+          </a:ln>
         </p:spPr>
       </p:sp>
       <p:sp>
@@ -14437,14 +14411,12 @@
           <a:solidFill>
             <a:srgbClr val="F4F6FB"/>
           </a:solidFill>
-          <a:ln/>
-          <a:effectLst>
-            <a:outerShdw sx="100000" sy="100000" kx="0" ky="0" algn="bl" rotWithShape="0" blurRad="76200" dist="25400" dir="5400000">
-              <a:srgbClr val="9AA5B8">
-                <a:alpha val="22000"/>
-              </a:srgbClr>
-            </a:outerShdw>
-          </a:effectLst>
+          <a:ln w="9525">
+            <a:solidFill>
+              <a:srgbClr val="E1E6F0"/>
+            </a:solidFill>
+            <a:prstDash val="solid"/>
+          </a:ln>
         </p:spPr>
       </p:sp>
       <p:sp>
@@ -15061,14 +15033,12 @@
           <a:solidFill>
             <a:srgbClr val="F4F6FB"/>
           </a:solidFill>
-          <a:ln/>
-          <a:effectLst>
-            <a:outerShdw sx="100000" sy="100000" kx="0" ky="0" algn="bl" rotWithShape="0" blurRad="76200" dist="25400" dir="5400000">
-              <a:srgbClr val="9AA5B8">
-                <a:alpha val="22000"/>
-              </a:srgbClr>
-            </a:outerShdw>
-          </a:effectLst>
+          <a:ln w="9525">
+            <a:solidFill>
+              <a:srgbClr val="E1E6F0"/>
+            </a:solidFill>
+            <a:prstDash val="solid"/>
+          </a:ln>
         </p:spPr>
       </p:sp>
       <p:sp>
@@ -15267,14 +15237,12 @@
           <a:solidFill>
             <a:srgbClr val="F4F6FB"/>
           </a:solidFill>
-          <a:ln/>
-          <a:effectLst>
-            <a:outerShdw sx="100000" sy="100000" kx="0" ky="0" algn="bl" rotWithShape="0" blurRad="76200" dist="25400" dir="5400000">
-              <a:srgbClr val="9AA5B8">
-                <a:alpha val="22000"/>
-              </a:srgbClr>
-            </a:outerShdw>
-          </a:effectLst>
+          <a:ln w="9525">
+            <a:solidFill>
+              <a:srgbClr val="E1E6F0"/>
+            </a:solidFill>
+            <a:prstDash val="solid"/>
+          </a:ln>
         </p:spPr>
       </p:sp>
       <p:sp>
@@ -15664,14 +15632,12 @@
           <a:solidFill>
             <a:srgbClr val="F4F6FB"/>
           </a:solidFill>
-          <a:ln/>
-          <a:effectLst>
-            <a:outerShdw sx="100000" sy="100000" kx="0" ky="0" algn="bl" rotWithShape="0" blurRad="76200" dist="25400" dir="5400000">
-              <a:srgbClr val="9AA5B8">
-                <a:alpha val="22000"/>
-              </a:srgbClr>
-            </a:outerShdw>
-          </a:effectLst>
+          <a:ln w="9525">
+            <a:solidFill>
+              <a:srgbClr val="E1E6F0"/>
+            </a:solidFill>
+            <a:prstDash val="solid"/>
+          </a:ln>
         </p:spPr>
       </p:sp>
       <p:sp>
@@ -15894,14 +15860,12 @@
           <a:solidFill>
             <a:srgbClr val="F4F6FB"/>
           </a:solidFill>
-          <a:ln/>
-          <a:effectLst>
-            <a:outerShdw sx="100000" sy="100000" kx="0" ky="0" algn="bl" rotWithShape="0" blurRad="76200" dist="25400" dir="5400000">
-              <a:srgbClr val="9AA5B8">
-                <a:alpha val="22000"/>
-              </a:srgbClr>
-            </a:outerShdw>
-          </a:effectLst>
+          <a:ln w="9525">
+            <a:solidFill>
+              <a:srgbClr val="E1E6F0"/>
+            </a:solidFill>
+            <a:prstDash val="solid"/>
+          </a:ln>
         </p:spPr>
       </p:sp>
       <p:sp>
@@ -17107,14 +17071,12 @@
           <a:solidFill>
             <a:srgbClr val="F4F6FB"/>
           </a:solidFill>
-          <a:ln/>
-          <a:effectLst>
-            <a:outerShdw sx="100000" sy="100000" kx="0" ky="0" algn="bl" rotWithShape="0" blurRad="76200" dist="25400" dir="5400000">
-              <a:srgbClr val="9AA5B8">
-                <a:alpha val="22000"/>
-              </a:srgbClr>
-            </a:outerShdw>
-          </a:effectLst>
+          <a:ln w="9525">
+            <a:solidFill>
+              <a:srgbClr val="E1E6F0"/>
+            </a:solidFill>
+            <a:prstDash val="solid"/>
+          </a:ln>
         </p:spPr>
       </p:sp>
       <p:sp>
@@ -17340,14 +17302,12 @@
           <a:solidFill>
             <a:srgbClr val="F4F6FB"/>
           </a:solidFill>
-          <a:ln/>
-          <a:effectLst>
-            <a:outerShdw sx="100000" sy="100000" kx="0" ky="0" algn="bl" rotWithShape="0" blurRad="76200" dist="25400" dir="5400000">
-              <a:srgbClr val="9AA5B8">
-                <a:alpha val="22000"/>
-              </a:srgbClr>
-            </a:outerShdw>
-          </a:effectLst>
+          <a:ln w="9525">
+            <a:solidFill>
+              <a:srgbClr val="E1E6F0"/>
+            </a:solidFill>
+            <a:prstDash val="solid"/>
+          </a:ln>
         </p:spPr>
       </p:sp>
       <p:sp>
@@ -17573,14 +17533,12 @@
           <a:solidFill>
             <a:srgbClr val="F4F6FB"/>
           </a:solidFill>
-          <a:ln/>
-          <a:effectLst>
-            <a:outerShdw sx="100000" sy="100000" kx="0" ky="0" algn="bl" rotWithShape="0" blurRad="76200" dist="25400" dir="5400000">
-              <a:srgbClr val="9AA5B8">
-                <a:alpha val="22000"/>
-              </a:srgbClr>
-            </a:outerShdw>
-          </a:effectLst>
+          <a:ln w="9525">
+            <a:solidFill>
+              <a:srgbClr val="E1E6F0"/>
+            </a:solidFill>
+            <a:prstDash val="solid"/>
+          </a:ln>
         </p:spPr>
       </p:sp>
       <p:sp>
@@ -18295,14 +18253,12 @@
           <a:solidFill>
             <a:srgbClr val="F4F6FB"/>
           </a:solidFill>
-          <a:ln/>
-          <a:effectLst>
-            <a:outerShdw sx="100000" sy="100000" kx="0" ky="0" algn="bl" rotWithShape="0" blurRad="76200" dist="25400" dir="5400000">
-              <a:srgbClr val="9AA5B8">
-                <a:alpha val="25000"/>
-              </a:srgbClr>
-            </a:outerShdw>
-          </a:effectLst>
+          <a:ln w="9525">
+            <a:solidFill>
+              <a:srgbClr val="E1E6F0"/>
+            </a:solidFill>
+            <a:prstDash val="solid"/>
+          </a:ln>
         </p:spPr>
       </p:sp>
       <p:sp>
@@ -18452,14 +18408,12 @@
           <a:solidFill>
             <a:srgbClr val="F4F6FB"/>
           </a:solidFill>
-          <a:ln/>
-          <a:effectLst>
-            <a:outerShdw sx="100000" sy="100000" kx="0" ky="0" algn="bl" rotWithShape="0" blurRad="76200" dist="25400" dir="5400000">
-              <a:srgbClr val="9AA5B8">
-                <a:alpha val="25000"/>
-              </a:srgbClr>
-            </a:outerShdw>
-          </a:effectLst>
+          <a:ln w="9525">
+            <a:solidFill>
+              <a:srgbClr val="E1E6F0"/>
+            </a:solidFill>
+            <a:prstDash val="solid"/>
+          </a:ln>
         </p:spPr>
       </p:sp>
       <p:sp>
@@ -18609,14 +18563,12 @@
           <a:solidFill>
             <a:srgbClr val="F4F6FB"/>
           </a:solidFill>
-          <a:ln/>
-          <a:effectLst>
-            <a:outerShdw sx="100000" sy="100000" kx="0" ky="0" algn="bl" rotWithShape="0" blurRad="76200" dist="25400" dir="5400000">
-              <a:srgbClr val="9AA5B8">
-                <a:alpha val="25000"/>
-              </a:srgbClr>
-            </a:outerShdw>
-          </a:effectLst>
+          <a:ln w="9525">
+            <a:solidFill>
+              <a:srgbClr val="E1E6F0"/>
+            </a:solidFill>
+            <a:prstDash val="solid"/>
+          </a:ln>
         </p:spPr>
       </p:sp>
       <p:sp>
@@ -18957,14 +18909,12 @@
           <a:solidFill>
             <a:srgbClr val="F4F6FB"/>
           </a:solidFill>
-          <a:ln/>
-          <a:effectLst>
-            <a:outerShdw sx="100000" sy="100000" kx="0" ky="0" algn="bl" rotWithShape="0" blurRad="76200" dist="25400" dir="5400000">
-              <a:srgbClr val="9AA5B8">
-                <a:alpha val="22000"/>
-              </a:srgbClr>
-            </a:outerShdw>
-          </a:effectLst>
+          <a:ln w="9525">
+            <a:solidFill>
+              <a:srgbClr val="E1E6F0"/>
+            </a:solidFill>
+            <a:prstDash val="solid"/>
+          </a:ln>
         </p:spPr>
       </p:sp>
       <p:sp>
@@ -19165,14 +19115,12 @@
           <a:solidFill>
             <a:srgbClr val="F4F6FB"/>
           </a:solidFill>
-          <a:ln/>
-          <a:effectLst>
-            <a:outerShdw sx="100000" sy="100000" kx="0" ky="0" algn="bl" rotWithShape="0" blurRad="76200" dist="25400" dir="5400000">
-              <a:srgbClr val="9AA5B8">
-                <a:alpha val="22000"/>
-              </a:srgbClr>
-            </a:outerShdw>
-          </a:effectLst>
+          <a:ln w="9525">
+            <a:solidFill>
+              <a:srgbClr val="E1E6F0"/>
+            </a:solidFill>
+            <a:prstDash val="solid"/>
+          </a:ln>
         </p:spPr>
       </p:sp>
       <p:sp>
@@ -19373,14 +19321,12 @@
           <a:solidFill>
             <a:srgbClr val="F4F6FB"/>
           </a:solidFill>
-          <a:ln/>
-          <a:effectLst>
-            <a:outerShdw sx="100000" sy="100000" kx="0" ky="0" algn="bl" rotWithShape="0" blurRad="76200" dist="25400" dir="5400000">
-              <a:srgbClr val="9AA5B8">
-                <a:alpha val="22000"/>
-              </a:srgbClr>
-            </a:outerShdw>
-          </a:effectLst>
+          <a:ln w="9525">
+            <a:solidFill>
+              <a:srgbClr val="E1E6F0"/>
+            </a:solidFill>
+            <a:prstDash val="solid"/>
+          </a:ln>
         </p:spPr>
       </p:sp>
       <p:sp>
@@ -19581,14 +19527,12 @@
           <a:solidFill>
             <a:srgbClr val="F4F6FB"/>
           </a:solidFill>
-          <a:ln/>
-          <a:effectLst>
-            <a:outerShdw sx="100000" sy="100000" kx="0" ky="0" algn="bl" rotWithShape="0" blurRad="76200" dist="25400" dir="5400000">
-              <a:srgbClr val="9AA5B8">
-                <a:alpha val="22000"/>
-              </a:srgbClr>
-            </a:outerShdw>
-          </a:effectLst>
+          <a:ln w="9525">
+            <a:solidFill>
+              <a:srgbClr val="E1E6F0"/>
+            </a:solidFill>
+            <a:prstDash val="solid"/>
+          </a:ln>
         </p:spPr>
       </p:sp>
       <p:sp>
@@ -19789,14 +19733,12 @@
           <a:solidFill>
             <a:srgbClr val="F4F6FB"/>
           </a:solidFill>
-          <a:ln/>
-          <a:effectLst>
-            <a:outerShdw sx="100000" sy="100000" kx="0" ky="0" algn="bl" rotWithShape="0" blurRad="76200" dist="25400" dir="5400000">
-              <a:srgbClr val="9AA5B8">
-                <a:alpha val="22000"/>
-              </a:srgbClr>
-            </a:outerShdw>
-          </a:effectLst>
+          <a:ln w="9525">
+            <a:solidFill>
+              <a:srgbClr val="E1E6F0"/>
+            </a:solidFill>
+            <a:prstDash val="solid"/>
+          </a:ln>
         </p:spPr>
       </p:sp>
       <p:sp>
@@ -20188,14 +20130,12 @@
           <a:solidFill>
             <a:srgbClr val="F4F6FB"/>
           </a:solidFill>
-          <a:ln/>
-          <a:effectLst>
-            <a:outerShdw sx="100000" sy="100000" kx="0" ky="0" algn="bl" rotWithShape="0" blurRad="76200" dist="25400" dir="5400000">
-              <a:srgbClr val="9AA5B8">
-                <a:alpha val="25000"/>
-              </a:srgbClr>
-            </a:outerShdw>
-          </a:effectLst>
+          <a:ln w="9525">
+            <a:solidFill>
+              <a:srgbClr val="E1E6F0"/>
+            </a:solidFill>
+            <a:prstDash val="solid"/>
+          </a:ln>
         </p:spPr>
       </p:sp>
       <p:sp>
@@ -20381,14 +20321,12 @@
           <a:solidFill>
             <a:srgbClr val="F4F6FB"/>
           </a:solidFill>
-          <a:ln/>
-          <a:effectLst>
-            <a:outerShdw sx="100000" sy="100000" kx="0" ky="0" algn="bl" rotWithShape="0" blurRad="76200" dist="25400" dir="5400000">
-              <a:srgbClr val="9AA5B8">
-                <a:alpha val="25000"/>
-              </a:srgbClr>
-            </a:outerShdw>
-          </a:effectLst>
+          <a:ln w="9525">
+            <a:solidFill>
+              <a:srgbClr val="E1E6F0"/>
+            </a:solidFill>
+            <a:prstDash val="solid"/>
+          </a:ln>
         </p:spPr>
       </p:sp>
       <p:sp>
@@ -20574,14 +20512,12 @@
           <a:solidFill>
             <a:srgbClr val="F4F6FB"/>
           </a:solidFill>
-          <a:ln/>
-          <a:effectLst>
-            <a:outerShdw sx="100000" sy="100000" kx="0" ky="0" algn="bl" rotWithShape="0" blurRad="76200" dist="25400" dir="5400000">
-              <a:srgbClr val="9AA5B8">
-                <a:alpha val="25000"/>
-              </a:srgbClr>
-            </a:outerShdw>
-          </a:effectLst>
+          <a:ln w="9525">
+            <a:solidFill>
+              <a:srgbClr val="E1E6F0"/>
+            </a:solidFill>
+            <a:prstDash val="solid"/>
+          </a:ln>
         </p:spPr>
       </p:sp>
       <p:sp>
@@ -20767,14 +20703,12 @@
           <a:solidFill>
             <a:srgbClr val="F4F6FB"/>
           </a:solidFill>
-          <a:ln/>
-          <a:effectLst>
-            <a:outerShdw sx="100000" sy="100000" kx="0" ky="0" algn="bl" rotWithShape="0" blurRad="76200" dist="25400" dir="5400000">
-              <a:srgbClr val="9AA5B8">
-                <a:alpha val="25000"/>
-              </a:srgbClr>
-            </a:outerShdw>
-          </a:effectLst>
+          <a:ln w="9525">
+            <a:solidFill>
+              <a:srgbClr val="E1E6F0"/>
+            </a:solidFill>
+            <a:prstDash val="solid"/>
+          </a:ln>
         </p:spPr>
       </p:sp>
       <p:sp>
@@ -21405,14 +21339,12 @@
           <a:solidFill>
             <a:srgbClr val="F4F6FB"/>
           </a:solidFill>
-          <a:ln/>
-          <a:effectLst>
-            <a:outerShdw sx="100000" sy="100000" kx="0" ky="0" algn="bl" rotWithShape="0" blurRad="76200" dist="25400" dir="5400000">
-              <a:srgbClr val="9AA5B8">
-                <a:alpha val="22000"/>
-              </a:srgbClr>
-            </a:outerShdw>
-          </a:effectLst>
+          <a:ln w="9525">
+            <a:solidFill>
+              <a:srgbClr val="E1E6F0"/>
+            </a:solidFill>
+            <a:prstDash val="solid"/>
+          </a:ln>
         </p:spPr>
       </p:sp>
       <p:sp>
@@ -21686,14 +21618,12 @@
           <a:solidFill>
             <a:srgbClr val="F4F6FB"/>
           </a:solidFill>
-          <a:ln/>
-          <a:effectLst>
-            <a:outerShdw sx="100000" sy="100000" kx="0" ky="0" algn="bl" rotWithShape="0" blurRad="76200" dist="25400" dir="5400000">
-              <a:srgbClr val="9AA5B8">
-                <a:alpha val="22000"/>
-              </a:srgbClr>
-            </a:outerShdw>
-          </a:effectLst>
+          <a:ln w="9525">
+            <a:solidFill>
+              <a:srgbClr val="E1E6F0"/>
+            </a:solidFill>
+            <a:prstDash val="solid"/>
+          </a:ln>
         </p:spPr>
       </p:sp>
       <p:sp>
@@ -21967,14 +21897,12 @@
           <a:solidFill>
             <a:srgbClr val="F4F6FB"/>
           </a:solidFill>
-          <a:ln/>
-          <a:effectLst>
-            <a:outerShdw sx="100000" sy="100000" kx="0" ky="0" algn="bl" rotWithShape="0" blurRad="76200" dist="25400" dir="5400000">
-              <a:srgbClr val="9AA5B8">
-                <a:alpha val="22000"/>
-              </a:srgbClr>
-            </a:outerShdw>
-          </a:effectLst>
+          <a:ln w="9525">
+            <a:solidFill>
+              <a:srgbClr val="E1E6F0"/>
+            </a:solidFill>
+            <a:prstDash val="solid"/>
+          </a:ln>
         </p:spPr>
       </p:sp>
       <p:sp>

</xml_diff>